<commit_message>
Stage 7-8 recompute (Holm, LOPO, intervals), report v20, PPT v13
</commit_message>
<xml_diff>
--- a/experiment_files/351_stage10/reports/talk/src/Stage10_author_readout_talk.pptx
+++ b/experiment_files/351_stage10/reports/talk/src/Stage10_author_readout_talk.pptx
@@ -6880,7 +6880,7 @@
         <p:spPr>
           <a:xfrm rot="21510000">
             <a:off x="9098280" y="1737360"/>
-            <a:ext cx="2651760" cy="3840480"/>
+            <a:ext cx="2651760" cy="4572000"/>
           </a:xfrm>
           <a:prstGeom prst="rect">
             <a:avLst/>
@@ -7001,6 +7001,22 @@
                 <a:latin typeface="Patrick Hand"/>
               </a:rPr>
               <a:t>re-checked: team folds, title reuse removed</a:t>
+            </a:r>
+          </a:p>
+          <a:p>
+            <a:pPr algn="l">
+              <a:spcAft>
+                <a:spcPts val="900"/>
+              </a:spcAft>
+            </a:pPr>
+            <a:r>
+              <a:rPr sz="1800" b="0">
+                <a:solidFill>
+                  <a:srgbClr val="2B2D42"/>
+                </a:solidFill>
+                <a:latin typeface="Patrick Hand"/>
+              </a:rPr>
+              <a:t>scores the first name token only (mostly an initial); subtracts false_0 only</a:t>
             </a:r>
           </a:p>
           <a:p>

</xml_diff>